<commit_message>
link to bricks packages
</commit_message>
<xml_diff>
--- a/workshop.pptx
+++ b/workshop.pptx
@@ -6831,7 +6831,7 @@
         <p:spPr>
           <a:xfrm>
             <a:off x="1013791" y="1868556"/>
-            <a:ext cx="4671392" cy="2862322"/>
+            <a:ext cx="4671392" cy="3693319"/>
           </a:xfrm>
           <a:prstGeom prst="rect">
             <a:avLst/>
@@ -6914,6 +6914,26 @@
               <a:rPr lang="en-US" dirty="0"/>
               <a:t>Provide interface for get / find</a:t>
             </a:r>
+          </a:p>
+          <a:p>
+            <a:pPr marL="285750" indent="-285750">
+              <a:buFont typeface="Arial" panose="020B0604020202020204" pitchFamily="34" charset="0"/>
+              <a:buChar char="•"/>
+            </a:pPr>
+            <a:endParaRPr lang="en-US" dirty="0"/>
+          </a:p>
+          <a:p>
+            <a:pPr marL="285750" indent="-285750">
+              <a:buFont typeface="Arial" panose="020B0604020202020204" pitchFamily="34" charset="0"/>
+              <a:buChar char="•"/>
+            </a:pPr>
+            <a:r>
+              <a:rPr lang="en-US" dirty="0">
+                <a:hlinkClick r:id="rId2"/>
+              </a:rPr>
+              <a:t>Packages · Global Technology Applications</a:t>
+            </a:r>
+            <a:endParaRPr lang="en-US" dirty="0"/>
           </a:p>
           <a:p>
             <a:pPr marL="285750" indent="-285750">

</xml_diff>